<commit_message>
chore: 時間表重配 — Why/How 各 20、Agentic 30、Hands-on 70、收尾 10（總 160 min）
依使用者新規劃把重心移到 hands-on:
| 段 | 舊 | 新 |
| Seg1 Why MCP       | 40 | 20 |
| Seg2 How MCP Works | 40 | 20 |
| 休息                | 10 | 10 |
| Seg3 Agentic Loop  | 35 | 30 |
| Seg4 Hands-on      | 45 | 70 |
| Seg5 收尾           | 10 | 10 |
| 總                  |180 |160 |

更新:CLAUDE.md / README 段落表 + 各段 heading、04-hands-on-lab.md
(70 分時間配置重排:10/15/20/15/10)、build-04-slides.py(cover 70min +
schedule slide 重排)+ 04 pptx 重 build、docs/index.html + index-local.html
(timeline seg-time + 各段 duration tag)。

「三小時工作坊」活動時段名稱保留(160 min 內容 + 報到/Q&A buffer 在 3hr 時段內)。
</commit_message>
<xml_diff>
--- a/slides/04-hands-on-lab.pptx
+++ b/slides/04-hands-on-lab.pptx
@@ -3287,7 +3287,7 @@
                 </a:solidFill>
                 <a:latin typeface="Calibri"/>
               </a:rPr>
-              <a:t>Hands-on Lab  ·  45 minutes</a:t>
+              <a:t>Hands-on Lab  ·  70 minutes</a:t>
             </a:r>
           </a:p>
         </p:txBody>
@@ -7671,7 +7671,7 @@
                 </a:solidFill>
                 <a:latin typeface="Calibri"/>
               </a:rPr>
-              <a:t>45 分鐘後,你將親手擁有</a:t>
+              <a:t>70 分鐘後,你將親手擁有</a:t>
             </a:r>
           </a:p>
         </p:txBody>
@@ -8557,7 +8557,7 @@
                 </a:solidFill>
                 <a:latin typeface="Arial Black"/>
               </a:rPr>
-              <a:t>45 分鐘時間配置</a:t>
+              <a:t>70 分鐘時間配置</a:t>
             </a:r>
           </a:p>
         </p:txBody>
@@ -8592,7 +8592,7 @@
                 </a:solidFill>
                 <a:latin typeface="Calibri"/>
               </a:rPr>
-              <a:t>講師 8 min 引導 + 37 min 巡場陪跑</a:t>
+              <a:t>講師 10 min 引導 + 60 min 巡場陪跑</a:t>
             </a:r>
           </a:p>
         </p:txBody>
@@ -8864,7 +8864,7 @@
                 </a:solidFill>
                 <a:latin typeface="Consolas"/>
               </a:rPr>
-              <a:t>0–8</a:t>
+              <a:t>0–10</a:t>
             </a:r>
           </a:p>
         </p:txBody>
@@ -9013,7 +9013,7 @@
                 </a:solidFill>
                 <a:latin typeface="Consolas"/>
               </a:rPr>
-              <a:t>8–18</a:t>
+              <a:t>10–25</a:t>
             </a:r>
           </a:p>
         </p:txBody>
@@ -9118,7 +9118,7 @@
                 </a:solidFill>
                 <a:latin typeface="Consolas"/>
               </a:rPr>
-              <a:t>18–32</a:t>
+              <a:t>25–45</a:t>
             </a:r>
           </a:p>
         </p:txBody>
@@ -9267,7 +9267,7 @@
                 </a:solidFill>
                 <a:latin typeface="Consolas"/>
               </a:rPr>
-              <a:t>32–40</a:t>
+              <a:t>45–60</a:t>
             </a:r>
           </a:p>
         </p:txBody>
@@ -9302,7 +9302,7 @@
                 </a:solidFill>
                 <a:latin typeface="Calibri"/>
               </a:rPr>
-              <a:t>交叉展示 — 3–4 位老師 demo 自己領域</a:t>
+              <a:t>交叉展示 + L2/L3 試玩 — 老師 demo 自己領域</a:t>
             </a:r>
           </a:p>
         </p:txBody>
@@ -9372,7 +9372,7 @@
                 </a:solidFill>
                 <a:latin typeface="Consolas"/>
               </a:rPr>
-              <a:t>40–45</a:t>
+              <a:t>60–70</a:t>
             </a:r>
           </a:p>
         </p:txBody>

</xml_diff>

<commit_message>
fix(seg4-slides): hands-on 投影片對齊 Colab 現況
投影片還停在舊狀態(3 工具、L1-L3、無 Colab),跟 Colab notebook 對不上。修:
- quick_start boot log:3 工具 → 5 工具(+library +course),callout「5 支工具全 ✓」;
  副標加「零安裝可改用 Colab」
- L2/L3 preview → L1→L4(4 卡):加 L4 大資料集(course 3018 課),
  L2-L4 改標「Colab 內建·可現場試」(不再只是課後自修),callout 提 Colab 一鍵開
- outcomes 第 4 卡「L2/L3 挑戰路徑」→「L2-L4 進階關卡」,提 3018 課程大資料集

對齊後投影片講的工具數、Lab 關卡、執行路徑都跟 Colab 一致。
</commit_message>
<xml_diff>
--- a/slides/04-hands-on-lab.pptx
+++ b/slides/04-hands-on-lab.pptx
@@ -6505,7 +6505,7 @@
                 </a:solidFill>
                 <a:latin typeface="Calibri"/>
               </a:rPr>
-              <a:t>★   L 2 / L 3   P R E V I E W</a:t>
+              <a:t>★   L 1 → L 4   L A B   P A T H S</a:t>
             </a:r>
           </a:p>
         </p:txBody>
@@ -6534,13 +6534,13 @@
           <a:p>
             <a:pPr algn="l"/>
             <a:r>
-              <a:rPr sz="3150" b="1" i="0">
+              <a:rPr sz="2400" b="1" i="0">
                 <a:solidFill>
                   <a:srgbClr val="1F2937"/>
                 </a:solidFill>
                 <a:latin typeface="Arial Black"/>
               </a:rPr>
-              <a:t>L2 / L3 — 帶回去繼續深入</a:t>
+              <a:t>L1 → L4 — 課堂試 + 帶回家寫</a:t>
             </a:r>
           </a:p>
         </p:txBody>
@@ -6575,7 +6575,7 @@
                 </a:solidFill>
                 <a:latin typeface="Calibri"/>
               </a:rPr>
-              <a:t>課後自修,參考 mini-project/docs/labs/</a:t>
+              <a:t>Colab 已內建 L1-L4 可現場試;手冊在 mini-project/docs/labs/</a:t>
             </a:r>
           </a:p>
         </p:txBody>
@@ -6589,7 +6589,7 @@
         <p:spPr>
           <a:xfrm>
             <a:off x="377190" y="1851660"/>
-            <a:ext cx="2708910" cy="2537460"/>
+            <a:ext cx="2023110" cy="2537460"/>
           </a:xfrm>
           <a:prstGeom prst="roundRect">
             <a:avLst>
@@ -6671,8 +6671,8 @@
         </p:nvSpPr>
         <p:spPr>
           <a:xfrm>
-            <a:off x="2434589" y="2023110"/>
-            <a:ext cx="514350" cy="274320"/>
+            <a:off x="1680210" y="2023110"/>
+            <a:ext cx="582930" cy="274320"/>
           </a:xfrm>
           <a:prstGeom prst="roundRect">
             <a:avLst>
@@ -6719,8 +6719,8 @@
         </p:nvSpPr>
         <p:spPr>
           <a:xfrm>
-            <a:off x="2434589" y="2023110"/>
-            <a:ext cx="514350" cy="274320"/>
+            <a:off x="1680210" y="2023110"/>
+            <a:ext cx="582930" cy="274320"/>
           </a:xfrm>
           <a:prstGeom prst="rect">
             <a:avLst/>
@@ -6741,7 +6741,7 @@
                 </a:solidFill>
                 <a:latin typeface="Consolas"/>
               </a:rPr>
-              <a:t>完成</a:t>
+              <a:t>現場做</a:t>
             </a:r>
           </a:p>
         </p:txBody>
@@ -6755,7 +6755,7 @@
         <p:spPr>
           <a:xfrm>
             <a:off x="548640" y="2434589"/>
-            <a:ext cx="2366010" cy="411479"/>
+            <a:ext cx="1680210" cy="411479"/>
           </a:xfrm>
           <a:prstGeom prst="rect">
             <a:avLst/>
@@ -6790,7 +6790,7 @@
         <p:spPr>
           <a:xfrm>
             <a:off x="548640" y="2948939"/>
-            <a:ext cx="2366010" cy="1371600"/>
+            <a:ext cx="1680210" cy="1371600"/>
           </a:xfrm>
           <a:prstGeom prst="rect">
             <a:avLst/>
@@ -6809,13 +6809,13 @@
               </a:spcAft>
             </a:pPr>
             <a:r>
-              <a:rPr sz="1050" b="0" i="0">
+              <a:rPr sz="975" b="0" i="0">
                 <a:solidFill>
                   <a:srgbClr val="374151"/>
                 </a:solidFill>
                 <a:latin typeface="Calibri"/>
               </a:rPr>
-              <a:t>課堂現場必做</a:t>
+              <a:t>課堂必做</a:t>
             </a:r>
           </a:p>
           <a:p>
@@ -6825,7 +6825,7 @@
               </a:spcAft>
             </a:pPr>
             <a:r>
-              <a:rPr sz="1050" b="0" i="0">
+              <a:rPr sz="975" b="0" i="0">
                 <a:solidFill>
                   <a:srgbClr val="374151"/>
                 </a:solidFill>
@@ -6844,8 +6844,264 @@
         </p:nvSpPr>
         <p:spPr>
           <a:xfrm>
-            <a:off x="3223260" y="1851660"/>
-            <a:ext cx="2708910" cy="2537460"/>
+            <a:off x="2523744" y="1851660"/>
+            <a:ext cx="2023110" cy="2537460"/>
+          </a:xfrm>
+          <a:prstGeom prst="roundRect">
+            <a:avLst>
+              <a:gd name="adj" fmla="val 10000"/>
+            </a:avLst>
+          </a:prstGeom>
+          <a:solidFill>
+            <a:srgbClr val="EEE8FF"/>
+          </a:solidFill>
+          <a:ln w="19050">
+            <a:solidFill>
+              <a:srgbClr val="7B5CF5"/>
+            </a:solidFill>
+          </a:ln>
+          <a:effectLst/>
+        </p:spPr>
+        <p:style>
+          <a:lnRef idx="1">
+            <a:schemeClr val="accent1"/>
+          </a:lnRef>
+          <a:fillRef idx="3">
+            <a:schemeClr val="accent1"/>
+          </a:fillRef>
+          <a:effectRef idx="2">
+            <a:schemeClr val="accent1"/>
+          </a:effectRef>
+          <a:fontRef idx="minor">
+            <a:schemeClr val="lt1"/>
+          </a:fontRef>
+        </p:style>
+        <p:txBody>
+          <a:bodyPr rtlCol="0" anchor="ctr"/>
+          <a:lstStyle/>
+          <a:p>
+            <a:pPr algn="ctr"/>
+          </a:p>
+        </p:txBody>
+      </p:sp>
+      <p:sp>
+        <p:nvSpPr>
+          <p:cNvPr id="14" name="TextBox 13"/>
+          <p:cNvSpPr txBox="1"/>
+          <p:nvPr/>
+        </p:nvSpPr>
+        <p:spPr>
+          <a:xfrm>
+            <a:off x="2695194" y="1954530"/>
+            <a:ext cx="685800" cy="342900"/>
+          </a:xfrm>
+          <a:prstGeom prst="rect">
+            <a:avLst/>
+          </a:prstGeom>
+          <a:noFill/>
+        </p:spPr>
+        <p:txBody>
+          <a:bodyPr wrap="square" lIns="27432" rIns="27432" tIns="13716" bIns="13716" anchor="t">
+            <a:spAutoFit/>
+          </a:bodyPr>
+          <a:lstStyle/>
+          <a:p>
+            <a:pPr algn="l"/>
+            <a:r>
+              <a:rPr sz="1800" b="1" i="0">
+                <a:solidFill>
+                  <a:srgbClr val="7B5CF5"/>
+                </a:solidFill>
+                <a:latin typeface="Arial Black"/>
+              </a:rPr>
+              <a:t>L2</a:t>
+            </a:r>
+          </a:p>
+        </p:txBody>
+      </p:sp>
+      <p:sp>
+        <p:nvSpPr>
+          <p:cNvPr id="15" name="Rounded Rectangle 14"/>
+          <p:cNvSpPr/>
+          <p:nvPr/>
+        </p:nvSpPr>
+        <p:spPr>
+          <a:xfrm>
+            <a:off x="3826764" y="2023110"/>
+            <a:ext cx="582930" cy="274320"/>
+          </a:xfrm>
+          <a:prstGeom prst="roundRect">
+            <a:avLst>
+              <a:gd name="adj" fmla="val 10000"/>
+            </a:avLst>
+          </a:prstGeom>
+          <a:solidFill>
+            <a:srgbClr val="FFFFFF"/>
+          </a:solidFill>
+          <a:ln w="14287">
+            <a:solidFill>
+              <a:srgbClr val="7B5CF5"/>
+            </a:solidFill>
+          </a:ln>
+          <a:effectLst/>
+        </p:spPr>
+        <p:style>
+          <a:lnRef idx="1">
+            <a:schemeClr val="accent1"/>
+          </a:lnRef>
+          <a:fillRef idx="3">
+            <a:schemeClr val="accent1"/>
+          </a:fillRef>
+          <a:effectRef idx="2">
+            <a:schemeClr val="accent1"/>
+          </a:effectRef>
+          <a:fontRef idx="minor">
+            <a:schemeClr val="lt1"/>
+          </a:fontRef>
+        </p:style>
+        <p:txBody>
+          <a:bodyPr rtlCol="0" anchor="ctr"/>
+          <a:lstStyle/>
+          <a:p>
+            <a:pPr algn="ctr"/>
+          </a:p>
+        </p:txBody>
+      </p:sp>
+      <p:sp>
+        <p:nvSpPr>
+          <p:cNvPr id="16" name="TextBox 15"/>
+          <p:cNvSpPr txBox="1"/>
+          <p:nvPr/>
+        </p:nvSpPr>
+        <p:spPr>
+          <a:xfrm>
+            <a:off x="3826764" y="2023110"/>
+            <a:ext cx="582930" cy="274320"/>
+          </a:xfrm>
+          <a:prstGeom prst="rect">
+            <a:avLst/>
+          </a:prstGeom>
+          <a:noFill/>
+        </p:spPr>
+        <p:txBody>
+          <a:bodyPr wrap="square" lIns="27432" rIns="27432" tIns="13716" bIns="13716" anchor="ctr">
+            <a:spAutoFit/>
+          </a:bodyPr>
+          <a:lstStyle/>
+          <a:p>
+            <a:pPr algn="ctr"/>
+            <a:r>
+              <a:rPr sz="750" b="1" i="0">
+                <a:solidFill>
+                  <a:srgbClr val="7B5CF5"/>
+                </a:solidFill>
+                <a:latin typeface="Consolas"/>
+              </a:rPr>
+              <a:t>可現場試</a:t>
+            </a:r>
+          </a:p>
+        </p:txBody>
+      </p:sp>
+      <p:sp>
+        <p:nvSpPr>
+          <p:cNvPr id="17" name="TextBox 16"/>
+          <p:cNvSpPr txBox="1"/>
+          <p:nvPr/>
+        </p:nvSpPr>
+        <p:spPr>
+          <a:xfrm>
+            <a:off x="2695194" y="2434589"/>
+            <a:ext cx="1680210" cy="411479"/>
+          </a:xfrm>
+          <a:prstGeom prst="rect">
+            <a:avLst/>
+          </a:prstGeom>
+          <a:noFill/>
+        </p:spPr>
+        <p:txBody>
+          <a:bodyPr wrap="square" lIns="27432" rIns="27432" tIns="13716" bIns="13716" anchor="t">
+            <a:spAutoFit/>
+          </a:bodyPr>
+          <a:lstStyle/>
+          <a:p>
+            <a:pPr algn="l"/>
+            <a:r>
+              <a:rPr sz="1125" b="1" i="0">
+                <a:solidFill>
+                  <a:srgbClr val="1F2937"/>
+                </a:solidFill>
+                <a:latin typeface="Arial Black"/>
+              </a:rPr>
+              <a:t>有參數的搜尋工具</a:t>
+            </a:r>
+          </a:p>
+        </p:txBody>
+      </p:sp>
+      <p:sp>
+        <p:nvSpPr>
+          <p:cNvPr id="18" name="TextBox 17"/>
+          <p:cNvSpPr txBox="1"/>
+          <p:nvPr/>
+        </p:nvSpPr>
+        <p:spPr>
+          <a:xfrm>
+            <a:off x="2695194" y="2948939"/>
+            <a:ext cx="1680210" cy="1371600"/>
+          </a:xfrm>
+          <a:prstGeom prst="rect">
+            <a:avLst/>
+          </a:prstGeom>
+          <a:noFill/>
+        </p:spPr>
+        <p:txBody>
+          <a:bodyPr wrap="square" lIns="27432" rIns="27432" tIns="13716" bIns="13716" anchor="t">
+            <a:spAutoFit/>
+          </a:bodyPr>
+          <a:lstStyle/>
+          <a:p>
+            <a:pPr algn="l">
+              <a:spcAft>
+                <a:spcPts val="450"/>
+              </a:spcAft>
+            </a:pPr>
+            <a:r>
+              <a:rPr sz="975" b="0" i="0">
+                <a:solidFill>
+                  <a:srgbClr val="374151"/>
+                </a:solidFill>
+                <a:latin typeface="Calibri"/>
+              </a:rPr>
+              <a:t>Colab 內建</a:t>
+            </a:r>
+          </a:p>
+          <a:p>
+            <a:pPr algn="l">
+              <a:spcAft>
+                <a:spcPts val="450"/>
+              </a:spcAft>
+            </a:pPr>
+            <a:r>
+              <a:rPr sz="975" b="0" i="0">
+                <a:solidFill>
+                  <a:srgbClr val="374151"/>
+                </a:solidFill>
+                <a:latin typeface="Calibri"/>
+              </a:rPr>
+              <a:t>teachers_tool</a:t>
+            </a:r>
+          </a:p>
+        </p:txBody>
+      </p:sp>
+      <p:sp>
+        <p:nvSpPr>
+          <p:cNvPr id="19" name="Rounded Rectangle 18"/>
+          <p:cNvSpPr/>
+          <p:nvPr/>
+        </p:nvSpPr>
+        <p:spPr>
+          <a:xfrm>
+            <a:off x="4670298" y="1851660"/>
+            <a:ext cx="2023110" cy="2537460"/>
           </a:xfrm>
           <a:prstGeom prst="roundRect">
             <a:avLst>
@@ -6886,13 +7142,13 @@
       </p:sp>
       <p:sp>
         <p:nvSpPr>
-          <p:cNvPr id="14" name="TextBox 13"/>
-          <p:cNvSpPr txBox="1"/>
-          <p:nvPr/>
-        </p:nvSpPr>
-        <p:spPr>
-          <a:xfrm>
-            <a:off x="3394710" y="1954530"/>
+          <p:cNvPr id="20" name="TextBox 19"/>
+          <p:cNvSpPr txBox="1"/>
+          <p:nvPr/>
+        </p:nvSpPr>
+        <p:spPr>
+          <a:xfrm>
+            <a:off x="4841748" y="1954530"/>
             <a:ext cx="685800" cy="342900"/>
           </a:xfrm>
           <a:prstGeom prst="rect">
@@ -6914,21 +7170,21 @@
                 </a:solidFill>
                 <a:latin typeface="Arial Black"/>
               </a:rPr>
-              <a:t>L2</a:t>
-            </a:r>
-          </a:p>
-        </p:txBody>
-      </p:sp>
-      <p:sp>
-        <p:nvSpPr>
-          <p:cNvPr id="15" name="Rounded Rectangle 14"/>
+              <a:t>L3</a:t>
+            </a:r>
+          </a:p>
+        </p:txBody>
+      </p:sp>
+      <p:sp>
+        <p:nvSpPr>
+          <p:cNvPr id="21" name="Rounded Rectangle 20"/>
           <p:cNvSpPr/>
           <p:nvPr/>
         </p:nvSpPr>
         <p:spPr>
           <a:xfrm>
-            <a:off x="5280660" y="2023110"/>
-            <a:ext cx="514350" cy="274320"/>
+            <a:off x="5973318" y="2023110"/>
+            <a:ext cx="582930" cy="274320"/>
           </a:xfrm>
           <a:prstGeom prst="roundRect">
             <a:avLst>
@@ -6969,14 +7225,14 @@
       </p:sp>
       <p:sp>
         <p:nvSpPr>
-          <p:cNvPr id="16" name="TextBox 15"/>
-          <p:cNvSpPr txBox="1"/>
-          <p:nvPr/>
-        </p:nvSpPr>
-        <p:spPr>
-          <a:xfrm>
-            <a:off x="5280660" y="2023110"/>
-            <a:ext cx="514350" cy="274320"/>
+          <p:cNvPr id="22" name="TextBox 21"/>
+          <p:cNvSpPr txBox="1"/>
+          <p:nvPr/>
+        </p:nvSpPr>
+        <p:spPr>
+          <a:xfrm>
+            <a:off x="5973318" y="2023110"/>
+            <a:ext cx="582930" cy="274320"/>
           </a:xfrm>
           <a:prstGeom prst="rect">
             <a:avLst/>
@@ -6997,21 +7253,21 @@
                 </a:solidFill>
                 <a:latin typeface="Consolas"/>
               </a:rPr>
-              <a:t>+1 hr</a:t>
-            </a:r>
-          </a:p>
-        </p:txBody>
-      </p:sp>
-      <p:sp>
-        <p:nvSpPr>
-          <p:cNvPr id="17" name="TextBox 16"/>
-          <p:cNvSpPr txBox="1"/>
-          <p:nvPr/>
-        </p:nvSpPr>
-        <p:spPr>
-          <a:xfrm>
-            <a:off x="3394710" y="2434589"/>
-            <a:ext cx="2366010" cy="411479"/>
+              <a:t>可現場試</a:t>
+            </a:r>
+          </a:p>
+        </p:txBody>
+      </p:sp>
+      <p:sp>
+        <p:nvSpPr>
+          <p:cNvPr id="23" name="TextBox 22"/>
+          <p:cNvSpPr txBox="1"/>
+          <p:nvPr/>
+        </p:nvSpPr>
+        <p:spPr>
+          <a:xfrm>
+            <a:off x="4841748" y="2434589"/>
+            <a:ext cx="1680210" cy="411479"/>
           </a:xfrm>
           <a:prstGeom prst="rect">
             <a:avLst/>
@@ -7032,21 +7288,21 @@
                 </a:solidFill>
                 <a:latin typeface="Arial Black"/>
               </a:rPr>
-              <a:t>加一支有參數的搜尋工具</a:t>
-            </a:r>
-          </a:p>
-        </p:txBody>
-      </p:sp>
-      <p:sp>
-        <p:nvSpPr>
-          <p:cNvPr id="18" name="TextBox 17"/>
-          <p:cNvSpPr txBox="1"/>
-          <p:nvPr/>
-        </p:nvSpPr>
-        <p:spPr>
-          <a:xfrm>
-            <a:off x="3394710" y="2948939"/>
-            <a:ext cx="2366010" cy="1371600"/>
+              <a:t>呼叫外部 API</a:t>
+            </a:r>
+          </a:p>
+        </p:txBody>
+      </p:sp>
+      <p:sp>
+        <p:nvSpPr>
+          <p:cNvPr id="24" name="TextBox 23"/>
+          <p:cNvSpPr txBox="1"/>
+          <p:nvPr/>
+        </p:nvSpPr>
+        <p:spPr>
+          <a:xfrm>
+            <a:off x="4841748" y="2948939"/>
+            <a:ext cx="1680210" cy="1371600"/>
           </a:xfrm>
           <a:prstGeom prst="rect">
             <a:avLst/>
@@ -7065,13 +7321,13 @@
               </a:spcAft>
             </a:pPr>
             <a:r>
-              <a:rPr sz="1050" b="0" i="0">
+              <a:rPr sz="975" b="0" i="0">
                 <a:solidFill>
                   <a:srgbClr val="374151"/>
                 </a:solidFill>
                 <a:latin typeface="Calibri"/>
               </a:rPr>
-              <a:t>課後自修</a:t>
+              <a:t>Colab 內建</a:t>
             </a:r>
           </a:p>
           <a:p>
@@ -7081,27 +7337,27 @@
               </a:spcAft>
             </a:pPr>
             <a:r>
-              <a:rPr sz="1050" b="0" i="0">
+              <a:rPr sz="975" b="0" i="0">
                 <a:solidFill>
                   <a:srgbClr val="374151"/>
                 </a:solidFill>
                 <a:latin typeface="Calibri"/>
               </a:rPr>
-              <a:t>寫一個 @mcp.tool()</a:t>
-            </a:r>
-          </a:p>
-        </p:txBody>
-      </p:sp>
-      <p:sp>
-        <p:nvSpPr>
-          <p:cNvPr id="19" name="Rounded Rectangle 18"/>
+              <a:t>library_tool(免 key)</a:t>
+            </a:r>
+          </a:p>
+        </p:txBody>
+      </p:sp>
+      <p:sp>
+        <p:nvSpPr>
+          <p:cNvPr id="25" name="Rounded Rectangle 24"/>
           <p:cNvSpPr/>
           <p:nvPr/>
         </p:nvSpPr>
         <p:spPr>
           <a:xfrm>
-            <a:off x="6069330" y="1851660"/>
-            <a:ext cx="2708910" cy="2537460"/>
+            <a:off x="6816852" y="1851660"/>
+            <a:ext cx="2023110" cy="2537460"/>
           </a:xfrm>
           <a:prstGeom prst="roundRect">
             <a:avLst>
@@ -7142,13 +7398,13 @@
       </p:sp>
       <p:sp>
         <p:nvSpPr>
-          <p:cNvPr id="20" name="TextBox 19"/>
-          <p:cNvSpPr txBox="1"/>
-          <p:nvPr/>
-        </p:nvSpPr>
-        <p:spPr>
-          <a:xfrm>
-            <a:off x="6240780" y="1954530"/>
+          <p:cNvPr id="26" name="TextBox 25"/>
+          <p:cNvSpPr txBox="1"/>
+          <p:nvPr/>
+        </p:nvSpPr>
+        <p:spPr>
+          <a:xfrm>
+            <a:off x="6988302" y="1954530"/>
             <a:ext cx="685800" cy="342900"/>
           </a:xfrm>
           <a:prstGeom prst="rect">
@@ -7170,21 +7426,21 @@
                 </a:solidFill>
                 <a:latin typeface="Arial Black"/>
               </a:rPr>
-              <a:t>L3</a:t>
-            </a:r>
-          </a:p>
-        </p:txBody>
-      </p:sp>
-      <p:sp>
-        <p:nvSpPr>
-          <p:cNvPr id="21" name="Rounded Rectangle 20"/>
+              <a:t>L4</a:t>
+            </a:r>
+          </a:p>
+        </p:txBody>
+      </p:sp>
+      <p:sp>
+        <p:nvSpPr>
+          <p:cNvPr id="27" name="Rounded Rectangle 26"/>
           <p:cNvSpPr/>
           <p:nvPr/>
         </p:nvSpPr>
         <p:spPr>
           <a:xfrm>
-            <a:off x="8126730" y="2023110"/>
-            <a:ext cx="514350" cy="274320"/>
+            <a:off x="8119871" y="2023110"/>
+            <a:ext cx="582930" cy="274320"/>
           </a:xfrm>
           <a:prstGeom prst="roundRect">
             <a:avLst>
@@ -7225,14 +7481,14 @@
       </p:sp>
       <p:sp>
         <p:nvSpPr>
-          <p:cNvPr id="22" name="TextBox 21"/>
-          <p:cNvSpPr txBox="1"/>
-          <p:nvPr/>
-        </p:nvSpPr>
-        <p:spPr>
-          <a:xfrm>
-            <a:off x="8126730" y="2023110"/>
-            <a:ext cx="514350" cy="274320"/>
+          <p:cNvPr id="28" name="TextBox 27"/>
+          <p:cNvSpPr txBox="1"/>
+          <p:nvPr/>
+        </p:nvSpPr>
+        <p:spPr>
+          <a:xfrm>
+            <a:off x="8119871" y="2023110"/>
+            <a:ext cx="582930" cy="274320"/>
           </a:xfrm>
           <a:prstGeom prst="rect">
             <a:avLst/>
@@ -7253,21 +7509,21 @@
                 </a:solidFill>
                 <a:latin typeface="Consolas"/>
               </a:rPr>
-              <a:t>+2 hr</a:t>
-            </a:r>
-          </a:p>
-        </p:txBody>
-      </p:sp>
-      <p:sp>
-        <p:nvSpPr>
-          <p:cNvPr id="23" name="TextBox 22"/>
-          <p:cNvSpPr txBox="1"/>
-          <p:nvPr/>
-        </p:nvSpPr>
-        <p:spPr>
-          <a:xfrm>
-            <a:off x="6240780" y="2434589"/>
-            <a:ext cx="2366010" cy="411479"/>
+              <a:t>可現場試</a:t>
+            </a:r>
+          </a:p>
+        </p:txBody>
+      </p:sp>
+      <p:sp>
+        <p:nvSpPr>
+          <p:cNvPr id="29" name="TextBox 28"/>
+          <p:cNvSpPr txBox="1"/>
+          <p:nvPr/>
+        </p:nvSpPr>
+        <p:spPr>
+          <a:xfrm>
+            <a:off x="6988302" y="2434589"/>
+            <a:ext cx="1680210" cy="411479"/>
           </a:xfrm>
           <a:prstGeom prst="rect">
             <a:avLst/>
@@ -7288,21 +7544,21 @@
                 </a:solidFill>
                 <a:latin typeface="Arial Black"/>
               </a:rPr>
-              <a:t>呼叫外部 API</a:t>
-            </a:r>
-          </a:p>
-        </p:txBody>
-      </p:sp>
-      <p:sp>
-        <p:nvSpPr>
-          <p:cNvPr id="24" name="TextBox 23"/>
-          <p:cNvSpPr txBox="1"/>
-          <p:nvPr/>
-        </p:nvSpPr>
-        <p:spPr>
-          <a:xfrm>
-            <a:off x="6240780" y="2948939"/>
-            <a:ext cx="2366010" cy="1371600"/>
+              <a:t>大資料集搜尋</a:t>
+            </a:r>
+          </a:p>
+        </p:txBody>
+      </p:sp>
+      <p:sp>
+        <p:nvSpPr>
+          <p:cNvPr id="30" name="TextBox 29"/>
+          <p:cNvSpPr txBox="1"/>
+          <p:nvPr/>
+        </p:nvSpPr>
+        <p:spPr>
+          <a:xfrm>
+            <a:off x="6988302" y="2948939"/>
+            <a:ext cx="1680210" cy="1371600"/>
           </a:xfrm>
           <a:prstGeom prst="rect">
             <a:avLst/>
@@ -7321,13 +7577,13 @@
               </a:spcAft>
             </a:pPr>
             <a:r>
-              <a:rPr sz="1050" b="0" i="0">
+              <a:rPr sz="975" b="0" i="0">
                 <a:solidFill>
                   <a:srgbClr val="374151"/>
                 </a:solidFill>
                 <a:latin typeface="Calibri"/>
               </a:rPr>
-              <a:t>課後自修</a:t>
+              <a:t>Colab 內建</a:t>
             </a:r>
           </a:p>
           <a:p>
@@ -7337,20 +7593,20 @@
               </a:spcAft>
             </a:pPr>
             <a:r>
-              <a:rPr sz="1050" b="0" i="0">
+              <a:rPr sz="975" b="0" i="0">
                 <a:solidFill>
                   <a:srgbClr val="374151"/>
                 </a:solidFill>
                 <a:latin typeface="Calibri"/>
               </a:rPr>
-              <a:t>串 arxiv/weather API</a:t>
-            </a:r>
-          </a:p>
-        </p:txBody>
-      </p:sp>
-      <p:sp>
-        <p:nvSpPr>
-          <p:cNvPr id="25" name="Rounded Rectangle 24"/>
+              <a:t>course 3018 門課</a:t>
+            </a:r>
+          </a:p>
+        </p:txBody>
+      </p:sp>
+      <p:sp>
+        <p:nvSpPr>
+          <p:cNvPr id="31" name="Rounded Rectangle 30"/>
           <p:cNvSpPr/>
           <p:nvPr/>
         </p:nvSpPr>
@@ -7398,7 +7654,7 @@
       </p:sp>
       <p:sp>
         <p:nvSpPr>
-          <p:cNvPr id="26" name="TextBox 25"/>
+          <p:cNvPr id="32" name="TextBox 31"/>
           <p:cNvSpPr txBox="1"/>
           <p:nvPr/>
         </p:nvSpPr>
@@ -7426,14 +7682,14 @@
                 </a:solidFill>
                 <a:latin typeface="Calibri"/>
               </a:rPr>
-              <a:t>▶  三關手冊:mini-project/docs/labs/L1-customize-your-data.md / L2 / L3</a:t>
-            </a:r>
-          </a:p>
-        </p:txBody>
-      </p:sp>
-      <p:sp>
-        <p:nvSpPr>
-          <p:cNvPr id="27" name="TextBox 26"/>
+              <a:t>▶  Colab 一鍵開(零安裝)現場試 L1-L4;想自己寫工具 → 手冊 docs/labs/</a:t>
+            </a:r>
+          </a:p>
+        </p:txBody>
+      </p:sp>
+      <p:sp>
+        <p:nvSpPr>
+          <p:cNvPr id="33" name="TextBox 32"/>
           <p:cNvSpPr txBox="1"/>
           <p:nvPr/>
         </p:nvSpPr>
@@ -8308,7 +8564,7 @@
                 </a:solidFill>
                 <a:latin typeface="Arial Black"/>
               </a:rPr>
-              <a:t>L2 / L3 挑戰路徑</a:t>
+              <a:t>L2–L4 進階關卡</a:t>
             </a:r>
           </a:p>
         </p:txBody>
@@ -8347,7 +8603,7 @@
                 </a:solidFill>
                 <a:latin typeface="Calibri"/>
               </a:rPr>
-              <a:t>帶回去繼續深入:加搜尋工具、呼叫外部 API</a:t>
+              <a:t>Colab 現場可試:參數搜尋、外部 API、3018 課程大資料集</a:t>
             </a:r>
           </a:p>
         </p:txBody>
@@ -12717,7 +12973,7 @@
                 </a:solidFill>
                 <a:latin typeface="Calibri"/>
               </a:rPr>
-              <a:t>三條指令 + 對照「該長什麼樣」</a:t>
+              <a:t>本機三條指令(零安裝可改用 Colab,見 README)+ 對照「該長什麼樣」</a:t>
             </a:r>
           </a:p>
         </p:txBody>
@@ -13081,7 +13337,7 @@
                 </a:solidFill>
                 <a:latin typeface="Consolas"/>
               </a:rPr>
-              <a:t>&gt; mini-assistant@1.0.0 start</a:t>
+              <a:t>&gt; node server.js</a:t>
             </a:r>
           </a:p>
           <a:p>
@@ -13093,11 +13349,11 @@
             <a:r>
               <a:rPr sz="750" b="0" i="0">
                 <a:solidFill>
-                  <a:srgbClr val="9CA3AF"/>
+                  <a:srgbClr val="A8E1B4"/>
                 </a:solidFill>
                 <a:latin typeface="Consolas"/>
               </a:rPr>
-              <a:t>&gt; node server.js</a:t>
+              <a:t>✓ hello_tool → get_english_center_info</a:t>
             </a:r>
           </a:p>
           <a:p>
@@ -13109,11 +13365,11 @@
             <a:r>
               <a:rPr sz="750" b="0" i="0">
                 <a:solidFill>
-                  <a:srgbClr val="E5E7EB"/>
+                  <a:srgbClr val="A8E1B4"/>
                 </a:solidFill>
                 <a:latin typeface="Consolas"/>
               </a:rPr>
-              <a:t> </a:t>
+              <a:t>✓ teachers_tool → search_teachers, get_teacher_detail</a:t>
             </a:r>
           </a:p>
           <a:p>
@@ -13129,7 +13385,7 @@
                 </a:solidFill>
                 <a:latin typeface="Consolas"/>
               </a:rPr>
-              <a:t>✓ hello_tool → get_english_center_info</a:t>
+              <a:t>✓ weather_tool → get_weather</a:t>
             </a:r>
           </a:p>
           <a:p>
@@ -13145,7 +13401,7 @@
                 </a:solidFill>
                 <a:latin typeface="Consolas"/>
               </a:rPr>
-              <a:t>✓ teachers_tool → search_teachers, get_teacher_detail</a:t>
+              <a:t>✓ library_tool → search_library</a:t>
             </a:r>
           </a:p>
           <a:p>
@@ -13161,7 +13417,7 @@
                 </a:solidFill>
                 <a:latin typeface="Consolas"/>
               </a:rPr>
-              <a:t>✓ weather_tool → get_weather</a:t>
+              <a:t>✓ course_tool → search_courses</a:t>
             </a:r>
           </a:p>
           <a:p>
@@ -13212,7 +13468,7 @@
                 </a:solidFill>
                 <a:latin typeface="Calibri"/>
               </a:rPr>
-              <a:t>★  三行 ✓ + URL → MCP server 都連上了</a:t>
+              <a:t>★  5 支工具全 ✓ + URL → MCP server 都連上了</a:t>
             </a:r>
           </a:p>
         </p:txBody>

</xml_diff>